<commit_message>
style: Community Hero와 탐색 레이아웃 보완
</commit_message>
<xml_diff>
--- a/output/presentation/techflow-community-ui-modernization.pptx
+++ b/output/presentation/techflow-community-ui-modernization.pptx
@@ -2,19 +2,19 @@
 <file path=ppt/presentation.xml><?xml version="1.0" encoding="utf-8"?>
 <p:presentation xmlns:p="http://schemas.openxmlformats.org/presentationml/2006/main">
   <p:sldMasterIdLst>
-    <p:sldMasterId xmlns:r="http://schemas.openxmlformats.org/officeDocument/2006/relationships" id="2147483648" r:id="R4323ed2c59ab4a48"/>
+    <p:sldMasterId xmlns:r="http://schemas.openxmlformats.org/officeDocument/2006/relationships" id="2147483648" r:id="R83284510fb2c4e6a"/>
   </p:sldMasterIdLst>
   <p:notesMasterIdLst>
-    <p:notesMasterId xmlns:r="http://schemas.openxmlformats.org/officeDocument/2006/relationships" r:id="R2ac1b75db5b54a3f"/>
+    <p:notesMasterId xmlns:r="http://schemas.openxmlformats.org/officeDocument/2006/relationships" r:id="Rb97b412fbf5d49f6"/>
   </p:notesMasterIdLst>
   <p:sldIdLst>
-    <p:sldId xmlns:r="http://schemas.openxmlformats.org/officeDocument/2006/relationships" id="256" r:id="R29902aa5288b4f46"/>
-    <p:sldId xmlns:r="http://schemas.openxmlformats.org/officeDocument/2006/relationships" id="257" r:id="R82200808d0ba46cd"/>
-    <p:sldId xmlns:r="http://schemas.openxmlformats.org/officeDocument/2006/relationships" id="258" r:id="R9459cd57773545b4"/>
-    <p:sldId xmlns:r="http://schemas.openxmlformats.org/officeDocument/2006/relationships" id="259" r:id="R58daa52f907e4816"/>
-    <p:sldId xmlns:r="http://schemas.openxmlformats.org/officeDocument/2006/relationships" id="260" r:id="R0498629cca9f484b"/>
-    <p:sldId xmlns:r="http://schemas.openxmlformats.org/officeDocument/2006/relationships" id="261" r:id="Rfbb6947407f24e94"/>
-    <p:sldId xmlns:r="http://schemas.openxmlformats.org/officeDocument/2006/relationships" id="262" r:id="R868b946573cd4b7e"/>
+    <p:sldId xmlns:r="http://schemas.openxmlformats.org/officeDocument/2006/relationships" id="256" r:id="R1a967ddc46a14adc"/>
+    <p:sldId xmlns:r="http://schemas.openxmlformats.org/officeDocument/2006/relationships" id="257" r:id="R5f15f6ccac1345ea"/>
+    <p:sldId xmlns:r="http://schemas.openxmlformats.org/officeDocument/2006/relationships" id="258" r:id="R1fea2b4f0b2443e7"/>
+    <p:sldId xmlns:r="http://schemas.openxmlformats.org/officeDocument/2006/relationships" id="259" r:id="Rf92d09e73e1e4986"/>
+    <p:sldId xmlns:r="http://schemas.openxmlformats.org/officeDocument/2006/relationships" id="260" r:id="R5ea16cb5e6c24b3f"/>
+    <p:sldId xmlns:r="http://schemas.openxmlformats.org/officeDocument/2006/relationships" id="261" r:id="R4208fce0a3b949c2"/>
+    <p:sldId xmlns:r="http://schemas.openxmlformats.org/officeDocument/2006/relationships" id="262" r:id="R098e1a5ba4474b2a"/>
   </p:sldIdLst>
   <p:sldSz cx="12192000" cy="6858000"/>
   <p:notesSz cx="6858000" cy="9144000"/>
@@ -1076,7 +1076,7 @@
   </p:cSld>
   <p:clrMap bg1="lt1" tx1="dk1" bg2="lt2" tx2="dk2" accent1="accent1" accent2="accent2" accent3="accent3" accent4="accent4" accent5="accent5" accent6="accent6" hlink="hlink" folHlink="folHlink"/>
   <p:sldLayoutIdLst>
-    <p:sldLayoutId xmlns:r="http://schemas.openxmlformats.org/officeDocument/2006/relationships" id="2147483649" r:id="Rfb8c9d92b24b49e7"/>
+    <p:sldLayoutId xmlns:r="http://schemas.openxmlformats.org/officeDocument/2006/relationships" id="2147483649" r:id="R8345dfe464324a28"/>
   </p:sldLayoutIdLst>
   <p:txStyles>
     <p:titleStyle>
@@ -1627,7 +1627,7 @@
           <p:cNvPr id="7" name="cover-kicker">
             <a:extLst xmlns:a="http://schemas.openxmlformats.org/drawingml/2006/main">
               <a:ext uri="{FF2B5EF4-FFF2-40B4-BE49-F238E27FC236}">
-                <a16:creationId xmlns:a16="http://schemas.microsoft.com/office/drawing/2014/main" id="{3383A91F-21B8-4498-BF9B-01E891F76360}"/>
+                <a16:creationId xmlns:a16="http://schemas.microsoft.com/office/drawing/2014/main" id="{B30C517E-02CD-47F7-B7FB-6A4A9F2C0223}"/>
               </a:ext>
             </a:extLst>
           </p:cNvPr>
@@ -1683,7 +1683,7 @@
           <p:cNvPr id="2" name="cover-title">
             <a:extLst xmlns:a="http://schemas.openxmlformats.org/drawingml/2006/main">
               <a:ext uri="{FF2B5EF4-FFF2-40B4-BE49-F238E27FC236}">
-                <a16:creationId xmlns:a16="http://schemas.microsoft.com/office/drawing/2014/main" id="{4FD253A8-C98C-4236-AA14-70A454EE2E85}"/>
+                <a16:creationId xmlns:a16="http://schemas.microsoft.com/office/drawing/2014/main" id="{AB7F3300-C30F-436E-B722-FD76091A9096}"/>
               </a:ext>
             </a:extLst>
           </p:cNvPr>
@@ -1762,7 +1762,7 @@
           <p:cNvPr id="3" name="cover-subtitle">
             <a:extLst xmlns:a="http://schemas.openxmlformats.org/drawingml/2006/main">
               <a:ext uri="{FF2B5EF4-FFF2-40B4-BE49-F238E27FC236}">
-                <a16:creationId xmlns:a16="http://schemas.microsoft.com/office/drawing/2014/main" id="{4654B557-AA2E-4933-A038-5468D31A3142}"/>
+                <a16:creationId xmlns:a16="http://schemas.microsoft.com/office/drawing/2014/main" id="{776B1FC0-5714-41D6-A0C6-4DD00F3AD449}"/>
               </a:ext>
             </a:extLst>
           </p:cNvPr>
@@ -1818,7 +1818,7 @@
           <p:cNvPr id="4" name="cover-image-frame">
             <a:extLst xmlns:a="http://schemas.openxmlformats.org/drawingml/2006/main">
               <a:ext uri="{FF2B5EF4-FFF2-40B4-BE49-F238E27FC236}">
-                <a16:creationId xmlns:a16="http://schemas.microsoft.com/office/drawing/2014/main" id="{4D5A548F-8989-43B9-8B7E-571E87E3C90B}"/>
+                <a16:creationId xmlns:a16="http://schemas.microsoft.com/office/drawing/2014/main" id="{3E47E418-CE4E-41DB-9ECD-70662FC6B20F}"/>
               </a:ext>
             </a:extLst>
           </p:cNvPr>
@@ -1857,7 +1857,7 @@
           <p:nvPr/>
         </p:nvPicPr>
         <p:blipFill>
-          <a:blip xmlns:r="http://schemas.openxmlformats.org/officeDocument/2006/relationships" xmlns:a="http://schemas.openxmlformats.org/drawingml/2006/main" r:embed="R2a84c82562ae4722"/>
+          <a:blip xmlns:r="http://schemas.openxmlformats.org/officeDocument/2006/relationships" xmlns:a="http://schemas.openxmlformats.org/drawingml/2006/main" r:embed="R351cc1dffecc43f0"/>
           <a:stretch xmlns:a="http://schemas.openxmlformats.org/drawingml/2006/main"/>
         </p:blipFill>
         <p:spPr>
@@ -1877,7 +1877,7 @@
           <p:cNvPr id="6" name="cover-status">
             <a:extLst xmlns:a="http://schemas.openxmlformats.org/drawingml/2006/main">
               <a:ext uri="{FF2B5EF4-FFF2-40B4-BE49-F238E27FC236}">
-                <a16:creationId xmlns:a16="http://schemas.microsoft.com/office/drawing/2014/main" id="{E68E7183-2E8D-4233-B2A6-2D26B78D5E56}"/>
+                <a16:creationId xmlns:a16="http://schemas.microsoft.com/office/drawing/2014/main" id="{F3ABF863-A594-457D-BC55-BDC23A83DDC1}"/>
               </a:ext>
             </a:extLst>
           </p:cNvPr>
@@ -1931,7 +1931,7 @@
     </p:spTree>
     <p:extLst>
       <p:ext uri="{BB962C8B-B14F-4D97-AF65-F5344CB8AC3E}">
-        <p14:creationId xmlns:p14="http://schemas.microsoft.com/office/powerpoint/2010/main" val="1846505965"/>
+        <p14:creationId xmlns:p14="http://schemas.microsoft.com/office/powerpoint/2010/main" val="1356351078"/>
       </p:ext>
     </p:extLst>
   </p:cSld>
@@ -1962,7 +1962,7 @@
           <p:cNvPr id="9" name="title-2">
             <a:extLst xmlns:a="http://schemas.openxmlformats.org/drawingml/2006/main">
               <a:ext uri="{FF2B5EF4-FFF2-40B4-BE49-F238E27FC236}">
-                <a16:creationId xmlns:a16="http://schemas.microsoft.com/office/drawing/2014/main" id="{580589C4-B7E9-4AA3-B671-4BDEE4AFACF5}"/>
+                <a16:creationId xmlns:a16="http://schemas.microsoft.com/office/drawing/2014/main" id="{8F834E69-3D26-4FA4-8F92-4AB62DE0A133}"/>
               </a:ext>
             </a:extLst>
           </p:cNvPr>
@@ -2018,7 +2018,7 @@
           <p:cNvPr id="2" name="page-2">
             <a:extLst xmlns:a="http://schemas.openxmlformats.org/drawingml/2006/main">
               <a:ext uri="{FF2B5EF4-FFF2-40B4-BE49-F238E27FC236}">
-                <a16:creationId xmlns:a16="http://schemas.microsoft.com/office/drawing/2014/main" id="{A73990A1-E581-4844-85FA-41CE04F4D72D}"/>
+                <a16:creationId xmlns:a16="http://schemas.microsoft.com/office/drawing/2014/main" id="{90A132A9-F840-4709-BDCF-9ECF3DC2C25E}"/>
               </a:ext>
             </a:extLst>
           </p:cNvPr>
@@ -2074,7 +2074,7 @@
           <p:cNvPr id="3" name="before-label">
             <a:extLst xmlns:a="http://schemas.openxmlformats.org/drawingml/2006/main">
               <a:ext uri="{FF2B5EF4-FFF2-40B4-BE49-F238E27FC236}">
-                <a16:creationId xmlns:a16="http://schemas.microsoft.com/office/drawing/2014/main" id="{10EE9B8C-6A55-4B3B-BBCB-D9C03E248D65}"/>
+                <a16:creationId xmlns:a16="http://schemas.microsoft.com/office/drawing/2014/main" id="{2BCD3387-73D4-427D-840E-DF406D47C5BF}"/>
               </a:ext>
             </a:extLst>
           </p:cNvPr>
@@ -2130,7 +2130,7 @@
           <p:cNvPr id="4" name="after-label">
             <a:extLst xmlns:a="http://schemas.openxmlformats.org/drawingml/2006/main">
               <a:ext uri="{FF2B5EF4-FFF2-40B4-BE49-F238E27FC236}">
-                <a16:creationId xmlns:a16="http://schemas.microsoft.com/office/drawing/2014/main" id="{0C7D763B-84F1-48DB-B696-54625AF499DC}"/>
+                <a16:creationId xmlns:a16="http://schemas.microsoft.com/office/drawing/2014/main" id="{3FF48F15-66D2-4E02-A402-EF3E08D98E40}"/>
               </a:ext>
             </a:extLst>
           </p:cNvPr>
@@ -2190,7 +2190,7 @@
           <p:nvPr/>
         </p:nvPicPr>
         <p:blipFill>
-          <a:blip xmlns:r="http://schemas.openxmlformats.org/officeDocument/2006/relationships" xmlns:a="http://schemas.openxmlformats.org/drawingml/2006/main" r:embed="Ra29c05c119834702"/>
+          <a:blip xmlns:r="http://schemas.openxmlformats.org/officeDocument/2006/relationships" xmlns:a="http://schemas.openxmlformats.org/drawingml/2006/main" r:embed="R4dd8a080a26a482b"/>
           <a:stretch xmlns:a="http://schemas.openxmlformats.org/drawingml/2006/main"/>
         </p:blipFill>
         <p:spPr>
@@ -2214,7 +2214,7 @@
           <p:nvPr/>
         </p:nvPicPr>
         <p:blipFill>
-          <a:blip xmlns:r="http://schemas.openxmlformats.org/officeDocument/2006/relationships" xmlns:a="http://schemas.openxmlformats.org/drawingml/2006/main" r:embed="Rbf75648e436a4827"/>
+          <a:blip xmlns:r="http://schemas.openxmlformats.org/officeDocument/2006/relationships" xmlns:a="http://schemas.openxmlformats.org/drawingml/2006/main" r:embed="R527004dc2efe499a"/>
           <a:stretch xmlns:a="http://schemas.openxmlformats.org/drawingml/2006/main"/>
         </p:blipFill>
         <p:spPr>
@@ -2234,7 +2234,7 @@
           <p:cNvPr id="7" name="before-copy">
             <a:extLst xmlns:a="http://schemas.openxmlformats.org/drawingml/2006/main">
               <a:ext uri="{FF2B5EF4-FFF2-40B4-BE49-F238E27FC236}">
-                <a16:creationId xmlns:a16="http://schemas.microsoft.com/office/drawing/2014/main" id="{A4534A8D-020E-4041-A167-F5DC46875822}"/>
+                <a16:creationId xmlns:a16="http://schemas.microsoft.com/office/drawing/2014/main" id="{A7452FD0-121D-49B0-9629-0C16A27F8D17}"/>
               </a:ext>
             </a:extLst>
           </p:cNvPr>
@@ -2290,7 +2290,7 @@
           <p:cNvPr id="8" name="after-copy">
             <a:extLst xmlns:a="http://schemas.openxmlformats.org/drawingml/2006/main">
               <a:ext uri="{FF2B5EF4-FFF2-40B4-BE49-F238E27FC236}">
-                <a16:creationId xmlns:a16="http://schemas.microsoft.com/office/drawing/2014/main" id="{9F05B65F-39F7-4188-9961-2AE11285B618}"/>
+                <a16:creationId xmlns:a16="http://schemas.microsoft.com/office/drawing/2014/main" id="{5043334E-AB41-4998-8A95-1D5917263A35}"/>
               </a:ext>
             </a:extLst>
           </p:cNvPr>
@@ -2318,7 +2318,7 @@
           <a:lstStyle xmlns:a="http://schemas.openxmlformats.org/drawingml/2006/main"/>
           <a:p xmlns:a="http://schemas.openxmlformats.org/drawingml/2006/main">
             <a:pPr algn="ctr">
-              <a:defRPr sz="1575" b="1">
+              <a:defRPr sz="1425" b="1">
                 <a:solidFill>
                   <a:srgbClr val="15253E"/>
                 </a:solidFill>
@@ -2328,7 +2328,7 @@
               </a:defRPr>
             </a:pPr>
             <a:r>
-              <a:rPr sz="1575" b="1">
+              <a:rPr sz="1425" b="1">
                 <a:solidFill>
                   <a:srgbClr val="15253E"/>
                 </a:solidFill>
@@ -2336,7 +2336,7 @@
                 <a:ea typeface="Malgun Gothic"/>
                 <a:cs typeface="Malgun Gothic"/>
               </a:rPr>
-              <a:t>블루 Hero · 넉넉한 카드 여백 · 한글 상태 · 44px 조작</a:t>
+              <a:t>128px Hero · 28px 타이틀 · 240px 탐색 · 버튼 넘침 0px</a:t>
             </a:r>
           </a:p>
         </p:txBody>
@@ -2344,7 +2344,7 @@
     </p:spTree>
     <p:extLst>
       <p:ext uri="{BB962C8B-B14F-4D97-AF65-F5344CB8AC3E}">
-        <p14:creationId xmlns:p14="http://schemas.microsoft.com/office/powerpoint/2010/main" val="1435919711"/>
+        <p14:creationId xmlns:p14="http://schemas.microsoft.com/office/powerpoint/2010/main" val="1627751249"/>
       </p:ext>
     </p:extLst>
   </p:cSld>
@@ -2375,7 +2375,7 @@
           <p:cNvPr id="15" name="title-3">
             <a:extLst xmlns:a="http://schemas.openxmlformats.org/drawingml/2006/main">
               <a:ext uri="{FF2B5EF4-FFF2-40B4-BE49-F238E27FC236}">
-                <a16:creationId xmlns:a16="http://schemas.microsoft.com/office/drawing/2014/main" id="{D3837D8A-9A68-4EC0-91AA-3E8703153CFE}"/>
+                <a16:creationId xmlns:a16="http://schemas.microsoft.com/office/drawing/2014/main" id="{E35B2A2A-517B-4272-898B-2A046A2DC360}"/>
               </a:ext>
             </a:extLst>
           </p:cNvPr>
@@ -2431,7 +2431,7 @@
           <p:cNvPr id="2" name="page-3">
             <a:extLst xmlns:a="http://schemas.openxmlformats.org/drawingml/2006/main">
               <a:ext uri="{FF2B5EF4-FFF2-40B4-BE49-F238E27FC236}">
-                <a16:creationId xmlns:a16="http://schemas.microsoft.com/office/drawing/2014/main" id="{0E6DA27A-E755-4BC7-9E9A-5C8FFC8B4028}"/>
+                <a16:creationId xmlns:a16="http://schemas.microsoft.com/office/drawing/2014/main" id="{9C0A3593-1AB6-4176-8118-FA382F61EB4D}"/>
               </a:ext>
             </a:extLst>
           </p:cNvPr>
@@ -2487,7 +2487,7 @@
           <p:cNvPr id="3" name="state-0">
             <a:extLst xmlns:a="http://schemas.openxmlformats.org/drawingml/2006/main">
               <a:ext uri="{FF2B5EF4-FFF2-40B4-BE49-F238E27FC236}">
-                <a16:creationId xmlns:a16="http://schemas.microsoft.com/office/drawing/2014/main" id="{636B64CF-2FD0-46DB-8316-7AAA71E4B35B}"/>
+                <a16:creationId xmlns:a16="http://schemas.microsoft.com/office/drawing/2014/main" id="{44EE3C0F-D19C-422D-986E-5E4D6B709BDE}"/>
               </a:ext>
             </a:extLst>
           </p:cNvPr>
@@ -2522,7 +2522,7 @@
           <p:cNvPr id="4" name="state-label-0">
             <a:extLst xmlns:a="http://schemas.openxmlformats.org/drawingml/2006/main">
               <a:ext uri="{FF2B5EF4-FFF2-40B4-BE49-F238E27FC236}">
-                <a16:creationId xmlns:a16="http://schemas.microsoft.com/office/drawing/2014/main" id="{E500C165-7006-4E22-8052-0AB106F4538C}"/>
+                <a16:creationId xmlns:a16="http://schemas.microsoft.com/office/drawing/2014/main" id="{60A20C07-2808-4EEE-BF38-9A1A396EFCF6}"/>
               </a:ext>
             </a:extLst>
           </p:cNvPr>
@@ -2578,7 +2578,7 @@
           <p:cNvPr id="5" name="state-detail-0">
             <a:extLst xmlns:a="http://schemas.openxmlformats.org/drawingml/2006/main">
               <a:ext uri="{FF2B5EF4-FFF2-40B4-BE49-F238E27FC236}">
-                <a16:creationId xmlns:a16="http://schemas.microsoft.com/office/drawing/2014/main" id="{7F694103-997A-491E-9251-327AA93A3E73}"/>
+                <a16:creationId xmlns:a16="http://schemas.microsoft.com/office/drawing/2014/main" id="{19DF42A7-5B22-4B82-8B34-F234AC855E22}"/>
               </a:ext>
             </a:extLst>
           </p:cNvPr>
@@ -2634,7 +2634,7 @@
           <p:cNvPr id="6" name="state-1">
             <a:extLst xmlns:a="http://schemas.openxmlformats.org/drawingml/2006/main">
               <a:ext uri="{FF2B5EF4-FFF2-40B4-BE49-F238E27FC236}">
-                <a16:creationId xmlns:a16="http://schemas.microsoft.com/office/drawing/2014/main" id="{549F9B41-52CF-4721-AF15-7609E423FDED}"/>
+                <a16:creationId xmlns:a16="http://schemas.microsoft.com/office/drawing/2014/main" id="{FF9B2690-7305-480C-B838-F4836305B8EB}"/>
               </a:ext>
             </a:extLst>
           </p:cNvPr>
@@ -2669,7 +2669,7 @@
           <p:cNvPr id="7" name="state-label-1">
             <a:extLst xmlns:a="http://schemas.openxmlformats.org/drawingml/2006/main">
               <a:ext uri="{FF2B5EF4-FFF2-40B4-BE49-F238E27FC236}">
-                <a16:creationId xmlns:a16="http://schemas.microsoft.com/office/drawing/2014/main" id="{57D059EB-29F1-4FC2-9BDB-EB48E9DF0CE9}"/>
+                <a16:creationId xmlns:a16="http://schemas.microsoft.com/office/drawing/2014/main" id="{6A80EF6D-692F-4F25-A4C1-A69DF4E16AB1}"/>
               </a:ext>
             </a:extLst>
           </p:cNvPr>
@@ -2725,7 +2725,7 @@
           <p:cNvPr id="8" name="state-detail-1">
             <a:extLst xmlns:a="http://schemas.openxmlformats.org/drawingml/2006/main">
               <a:ext uri="{FF2B5EF4-FFF2-40B4-BE49-F238E27FC236}">
-                <a16:creationId xmlns:a16="http://schemas.microsoft.com/office/drawing/2014/main" id="{6EBA6FE6-1DC3-49C1-9E6D-83DFC25E7D64}"/>
+                <a16:creationId xmlns:a16="http://schemas.microsoft.com/office/drawing/2014/main" id="{7A79B4B4-D4CB-4170-86F4-7FCA95496391}"/>
               </a:ext>
             </a:extLst>
           </p:cNvPr>
@@ -2781,7 +2781,7 @@
           <p:cNvPr id="9" name="state-2">
             <a:extLst xmlns:a="http://schemas.openxmlformats.org/drawingml/2006/main">
               <a:ext uri="{FF2B5EF4-FFF2-40B4-BE49-F238E27FC236}">
-                <a16:creationId xmlns:a16="http://schemas.microsoft.com/office/drawing/2014/main" id="{56FC9D8D-B176-4297-858F-E57A4B426B7A}"/>
+                <a16:creationId xmlns:a16="http://schemas.microsoft.com/office/drawing/2014/main" id="{F1B6E346-1686-4F1E-B6BE-3A82E05A886B}"/>
               </a:ext>
             </a:extLst>
           </p:cNvPr>
@@ -2816,7 +2816,7 @@
           <p:cNvPr id="10" name="state-label-2">
             <a:extLst xmlns:a="http://schemas.openxmlformats.org/drawingml/2006/main">
               <a:ext uri="{FF2B5EF4-FFF2-40B4-BE49-F238E27FC236}">
-                <a16:creationId xmlns:a16="http://schemas.microsoft.com/office/drawing/2014/main" id="{98FF19C0-A503-4AC8-97A6-7DB7EA2E07BA}"/>
+                <a16:creationId xmlns:a16="http://schemas.microsoft.com/office/drawing/2014/main" id="{8F24D563-2FA6-4055-95AA-94BD01ED6D79}"/>
               </a:ext>
             </a:extLst>
           </p:cNvPr>
@@ -2872,7 +2872,7 @@
           <p:cNvPr id="11" name="state-detail-2">
             <a:extLst xmlns:a="http://schemas.openxmlformats.org/drawingml/2006/main">
               <a:ext uri="{FF2B5EF4-FFF2-40B4-BE49-F238E27FC236}">
-                <a16:creationId xmlns:a16="http://schemas.microsoft.com/office/drawing/2014/main" id="{59DD1760-E734-48D9-8F0F-296DD57A1622}"/>
+                <a16:creationId xmlns:a16="http://schemas.microsoft.com/office/drawing/2014/main" id="{7AEB40EC-3DA0-4A0D-8C01-C384A1AC9956}"/>
               </a:ext>
             </a:extLst>
           </p:cNvPr>
@@ -2928,7 +2928,7 @@
           <p:cNvPr id="12" name="state-3">
             <a:extLst xmlns:a="http://schemas.openxmlformats.org/drawingml/2006/main">
               <a:ext uri="{FF2B5EF4-FFF2-40B4-BE49-F238E27FC236}">
-                <a16:creationId xmlns:a16="http://schemas.microsoft.com/office/drawing/2014/main" id="{C5A2AB33-B88D-454D-8A97-BAB9A38C088A}"/>
+                <a16:creationId xmlns:a16="http://schemas.microsoft.com/office/drawing/2014/main" id="{71E76F99-9DD9-4DED-8A6E-BFF2AC431D94}"/>
               </a:ext>
             </a:extLst>
           </p:cNvPr>
@@ -2963,7 +2963,7 @@
           <p:cNvPr id="13" name="state-label-3">
             <a:extLst xmlns:a="http://schemas.openxmlformats.org/drawingml/2006/main">
               <a:ext uri="{FF2B5EF4-FFF2-40B4-BE49-F238E27FC236}">
-                <a16:creationId xmlns:a16="http://schemas.microsoft.com/office/drawing/2014/main" id="{5C1FC302-C3CA-4F0F-9B1B-640BD6269E38}"/>
+                <a16:creationId xmlns:a16="http://schemas.microsoft.com/office/drawing/2014/main" id="{C69927BF-29FE-4BFB-A307-D50F58E7AEC8}"/>
               </a:ext>
             </a:extLst>
           </p:cNvPr>
@@ -3019,7 +3019,7 @@
           <p:cNvPr id="14" name="state-detail-3">
             <a:extLst xmlns:a="http://schemas.openxmlformats.org/drawingml/2006/main">
               <a:ext uri="{FF2B5EF4-FFF2-40B4-BE49-F238E27FC236}">
-                <a16:creationId xmlns:a16="http://schemas.microsoft.com/office/drawing/2014/main" id="{40941DC3-4513-4A4F-9AD4-99EDB444E86D}"/>
+                <a16:creationId xmlns:a16="http://schemas.microsoft.com/office/drawing/2014/main" id="{EC212F34-1579-49F5-9C60-4D38A2E0AD14}"/>
               </a:ext>
             </a:extLst>
           </p:cNvPr>
@@ -3073,7 +3073,7 @@
     </p:spTree>
     <p:extLst>
       <p:ext uri="{BB962C8B-B14F-4D97-AF65-F5344CB8AC3E}">
-        <p14:creationId xmlns:p14="http://schemas.microsoft.com/office/powerpoint/2010/main" val="1035959051"/>
+        <p14:creationId xmlns:p14="http://schemas.microsoft.com/office/powerpoint/2010/main" val="1569714647"/>
       </p:ext>
     </p:extLst>
   </p:cSld>
@@ -3104,7 +3104,7 @@
           <p:cNvPr id="11" name="title-4">
             <a:extLst xmlns:a="http://schemas.openxmlformats.org/drawingml/2006/main">
               <a:ext uri="{FF2B5EF4-FFF2-40B4-BE49-F238E27FC236}">
-                <a16:creationId xmlns:a16="http://schemas.microsoft.com/office/drawing/2014/main" id="{2F15FEEA-C6F5-424D-83D4-55BABD3675F2}"/>
+                <a16:creationId xmlns:a16="http://schemas.microsoft.com/office/drawing/2014/main" id="{364DDEE9-32AA-424D-8E5E-D1EDCA90C8FE}"/>
               </a:ext>
             </a:extLst>
           </p:cNvPr>
@@ -3160,7 +3160,7 @@
           <p:cNvPr id="2" name="page-4">
             <a:extLst xmlns:a="http://schemas.openxmlformats.org/drawingml/2006/main">
               <a:ext uri="{FF2B5EF4-FFF2-40B4-BE49-F238E27FC236}">
-                <a16:creationId xmlns:a16="http://schemas.microsoft.com/office/drawing/2014/main" id="{CB9751A4-DF02-4A22-8C21-23203702D9B1}"/>
+                <a16:creationId xmlns:a16="http://schemas.microsoft.com/office/drawing/2014/main" id="{0BA99E0B-A0F3-49AB-88F1-2426C3CE2102}"/>
               </a:ext>
             </a:extLst>
           </p:cNvPr>
@@ -3220,7 +3220,7 @@
           <p:nvPr/>
         </p:nvPicPr>
         <p:blipFill>
-          <a:blip xmlns:r="http://schemas.openxmlformats.org/officeDocument/2006/relationships" xmlns:a="http://schemas.openxmlformats.org/drawingml/2006/main" r:embed="Rec4814ea54df4c50"/>
+          <a:blip xmlns:r="http://schemas.openxmlformats.org/officeDocument/2006/relationships" xmlns:a="http://schemas.openxmlformats.org/drawingml/2006/main" r:embed="R7ba50e144fe844e4"/>
           <a:stretch xmlns:a="http://schemas.openxmlformats.org/drawingml/2006/main"/>
         </p:blipFill>
         <p:spPr>
@@ -3240,7 +3240,7 @@
           <p:cNvPr id="4" name="mobile-fact-1">
             <a:extLst xmlns:a="http://schemas.openxmlformats.org/drawingml/2006/main">
               <a:ext uri="{FF2B5EF4-FFF2-40B4-BE49-F238E27FC236}">
-                <a16:creationId xmlns:a16="http://schemas.microsoft.com/office/drawing/2014/main" id="{EA59F433-3E23-4CCB-8EA3-4463B2C16FDB}"/>
+                <a16:creationId xmlns:a16="http://schemas.microsoft.com/office/drawing/2014/main" id="{1ED04589-AECA-4ECD-B785-ABD2B20E5F99}"/>
               </a:ext>
             </a:extLst>
           </p:cNvPr>
@@ -3296,7 +3296,7 @@
           <p:cNvPr id="5" name="mobile-desc-1">
             <a:extLst xmlns:a="http://schemas.openxmlformats.org/drawingml/2006/main">
               <a:ext uri="{FF2B5EF4-FFF2-40B4-BE49-F238E27FC236}">
-                <a16:creationId xmlns:a16="http://schemas.microsoft.com/office/drawing/2014/main" id="{373D4433-A77F-4B84-93D9-1930DA384868}"/>
+                <a16:creationId xmlns:a16="http://schemas.microsoft.com/office/drawing/2014/main" id="{1D6DDF5C-E0C5-4B88-8A67-8695AE7EF33B}"/>
               </a:ext>
             </a:extLst>
           </p:cNvPr>
@@ -3352,7 +3352,7 @@
           <p:cNvPr id="6" name="mobile-fact-2">
             <a:extLst xmlns:a="http://schemas.openxmlformats.org/drawingml/2006/main">
               <a:ext uri="{FF2B5EF4-FFF2-40B4-BE49-F238E27FC236}">
-                <a16:creationId xmlns:a16="http://schemas.microsoft.com/office/drawing/2014/main" id="{58275460-FB05-411D-B02D-9252A4F1C701}"/>
+                <a16:creationId xmlns:a16="http://schemas.microsoft.com/office/drawing/2014/main" id="{B6748176-C57F-44B7-B51A-5DB5301CE2A8}"/>
               </a:ext>
             </a:extLst>
           </p:cNvPr>
@@ -3408,7 +3408,7 @@
           <p:cNvPr id="7" name="mobile-desc-2">
             <a:extLst xmlns:a="http://schemas.openxmlformats.org/drawingml/2006/main">
               <a:ext uri="{FF2B5EF4-FFF2-40B4-BE49-F238E27FC236}">
-                <a16:creationId xmlns:a16="http://schemas.microsoft.com/office/drawing/2014/main" id="{E260E1DC-E08D-4F90-A60C-BEC7B4AF8C10}"/>
+                <a16:creationId xmlns:a16="http://schemas.microsoft.com/office/drawing/2014/main" id="{1DCD3B08-338E-4060-B5E9-2367297C15B8}"/>
               </a:ext>
             </a:extLst>
           </p:cNvPr>
@@ -3464,7 +3464,7 @@
           <p:cNvPr id="8" name="mobile-fact-3">
             <a:extLst xmlns:a="http://schemas.openxmlformats.org/drawingml/2006/main">
               <a:ext uri="{FF2B5EF4-FFF2-40B4-BE49-F238E27FC236}">
-                <a16:creationId xmlns:a16="http://schemas.microsoft.com/office/drawing/2014/main" id="{6CE8AF66-EA2E-4CF9-8B9B-E76DF2DE0F9C}"/>
+                <a16:creationId xmlns:a16="http://schemas.microsoft.com/office/drawing/2014/main" id="{351D7747-9A75-4B88-A194-12002F37DBA7}"/>
               </a:ext>
             </a:extLst>
           </p:cNvPr>
@@ -3520,7 +3520,7 @@
           <p:cNvPr id="9" name="mobile-desc-3">
             <a:extLst xmlns:a="http://schemas.openxmlformats.org/drawingml/2006/main">
               <a:ext uri="{FF2B5EF4-FFF2-40B4-BE49-F238E27FC236}">
-                <a16:creationId xmlns:a16="http://schemas.microsoft.com/office/drawing/2014/main" id="{DAA544EE-D0D3-4995-8347-F2794F01EFC4}"/>
+                <a16:creationId xmlns:a16="http://schemas.microsoft.com/office/drawing/2014/main" id="{413C1D88-C228-4ABE-99E5-D6470B7D0CCB}"/>
               </a:ext>
             </a:extLst>
           </p:cNvPr>
@@ -3576,7 +3576,7 @@
           <p:cNvPr id="10" name="mobile-foot">
             <a:extLst xmlns:a="http://schemas.openxmlformats.org/drawingml/2006/main">
               <a:ext uri="{FF2B5EF4-FFF2-40B4-BE49-F238E27FC236}">
-                <a16:creationId xmlns:a16="http://schemas.microsoft.com/office/drawing/2014/main" id="{2AB98398-C233-4C7F-9E16-46DFCA172ED0}"/>
+                <a16:creationId xmlns:a16="http://schemas.microsoft.com/office/drawing/2014/main" id="{0A5760AE-27F5-499A-B46B-014DB29DBF4B}"/>
               </a:ext>
             </a:extLst>
           </p:cNvPr>
@@ -3630,7 +3630,7 @@
     </p:spTree>
     <p:extLst>
       <p:ext uri="{BB962C8B-B14F-4D97-AF65-F5344CB8AC3E}">
-        <p14:creationId xmlns:p14="http://schemas.microsoft.com/office/powerpoint/2010/main" val="127206879"/>
+        <p14:creationId xmlns:p14="http://schemas.microsoft.com/office/powerpoint/2010/main" val="2069577870"/>
       </p:ext>
     </p:extLst>
   </p:cSld>
@@ -3661,7 +3661,7 @@
           <p:cNvPr id="20" name="title-5">
             <a:extLst xmlns:a="http://schemas.openxmlformats.org/drawingml/2006/main">
               <a:ext uri="{FF2B5EF4-FFF2-40B4-BE49-F238E27FC236}">
-                <a16:creationId xmlns:a16="http://schemas.microsoft.com/office/drawing/2014/main" id="{6BB39D81-FAB5-40E3-8C37-5F642A85F56A}"/>
+                <a16:creationId xmlns:a16="http://schemas.microsoft.com/office/drawing/2014/main" id="{7C7115AC-2500-477F-A76B-032C779ED07C}"/>
               </a:ext>
             </a:extLst>
           </p:cNvPr>
@@ -3717,7 +3717,7 @@
           <p:cNvPr id="2" name="page-5">
             <a:extLst xmlns:a="http://schemas.openxmlformats.org/drawingml/2006/main">
               <a:ext uri="{FF2B5EF4-FFF2-40B4-BE49-F238E27FC236}">
-                <a16:creationId xmlns:a16="http://schemas.microsoft.com/office/drawing/2014/main" id="{62253063-E7AC-4BCF-BBC7-2D6E46369F82}"/>
+                <a16:creationId xmlns:a16="http://schemas.microsoft.com/office/drawing/2014/main" id="{867E932A-D99E-41C3-859A-F7D8243DF6C5}"/>
               </a:ext>
             </a:extLst>
           </p:cNvPr>
@@ -3773,7 +3773,7 @@
           <p:cNvPr id="3" name="arrow-0">
             <a:extLst xmlns:a="http://schemas.openxmlformats.org/drawingml/2006/main">
               <a:ext uri="{FF2B5EF4-FFF2-40B4-BE49-F238E27FC236}">
-                <a16:creationId xmlns:a16="http://schemas.microsoft.com/office/drawing/2014/main" id="{F83CE108-D5A7-406B-BB46-1891E63C64A7}"/>
+                <a16:creationId xmlns:a16="http://schemas.microsoft.com/office/drawing/2014/main" id="{02DA7620-22D1-468B-B978-439EECC6101A}"/>
               </a:ext>
             </a:extLst>
           </p:cNvPr>
@@ -3829,7 +3829,7 @@
           <p:cNvPr id="4" name="phase-0">
             <a:extLst xmlns:a="http://schemas.openxmlformats.org/drawingml/2006/main">
               <a:ext uri="{FF2B5EF4-FFF2-40B4-BE49-F238E27FC236}">
-                <a16:creationId xmlns:a16="http://schemas.microsoft.com/office/drawing/2014/main" id="{9D6CB411-3441-466D-907B-23D68BB900A1}"/>
+                <a16:creationId xmlns:a16="http://schemas.microsoft.com/office/drawing/2014/main" id="{65C31113-1990-4E1B-AFAC-6F4356129C6C}"/>
               </a:ext>
             </a:extLst>
           </p:cNvPr>
@@ -3864,7 +3864,7 @@
           <p:cNvPr id="5" name="phase-label-0">
             <a:extLst xmlns:a="http://schemas.openxmlformats.org/drawingml/2006/main">
               <a:ext uri="{FF2B5EF4-FFF2-40B4-BE49-F238E27FC236}">
-                <a16:creationId xmlns:a16="http://schemas.microsoft.com/office/drawing/2014/main" id="{B1D25370-BB38-40FF-9FE8-216457D5A331}"/>
+                <a16:creationId xmlns:a16="http://schemas.microsoft.com/office/drawing/2014/main" id="{6DED1DD9-7A5C-4E9F-A14C-5AD7AC93C183}"/>
               </a:ext>
             </a:extLst>
           </p:cNvPr>
@@ -3943,7 +3943,7 @@
           <p:cNvPr id="6" name="phase-http-0">
             <a:extLst xmlns:a="http://schemas.openxmlformats.org/drawingml/2006/main">
               <a:ext uri="{FF2B5EF4-FFF2-40B4-BE49-F238E27FC236}">
-                <a16:creationId xmlns:a16="http://schemas.microsoft.com/office/drawing/2014/main" id="{D034EF33-E754-4A5F-A744-690CD4E85173}"/>
+                <a16:creationId xmlns:a16="http://schemas.microsoft.com/office/drawing/2014/main" id="{FEF4294B-0EBC-4C49-897E-08644B1DBF2F}"/>
               </a:ext>
             </a:extLst>
           </p:cNvPr>
@@ -3999,7 +3999,7 @@
           <p:cNvPr id="7" name="arrow-1">
             <a:extLst xmlns:a="http://schemas.openxmlformats.org/drawingml/2006/main">
               <a:ext uri="{FF2B5EF4-FFF2-40B4-BE49-F238E27FC236}">
-                <a16:creationId xmlns:a16="http://schemas.microsoft.com/office/drawing/2014/main" id="{974A4E60-DA99-40EC-BDFA-F1F1DF2516E6}"/>
+                <a16:creationId xmlns:a16="http://schemas.microsoft.com/office/drawing/2014/main" id="{B3791DE9-44AD-4BA6-8BA0-ACFE8CED89C8}"/>
               </a:ext>
             </a:extLst>
           </p:cNvPr>
@@ -4055,7 +4055,7 @@
           <p:cNvPr id="8" name="phase-1">
             <a:extLst xmlns:a="http://schemas.openxmlformats.org/drawingml/2006/main">
               <a:ext uri="{FF2B5EF4-FFF2-40B4-BE49-F238E27FC236}">
-                <a16:creationId xmlns:a16="http://schemas.microsoft.com/office/drawing/2014/main" id="{4DA65038-233C-4076-8F19-0CD2BD7C89B3}"/>
+                <a16:creationId xmlns:a16="http://schemas.microsoft.com/office/drawing/2014/main" id="{0F9CF05A-D6DB-4883-9FB6-38C24BB3E76D}"/>
               </a:ext>
             </a:extLst>
           </p:cNvPr>
@@ -4090,7 +4090,7 @@
           <p:cNvPr id="9" name="phase-label-1">
             <a:extLst xmlns:a="http://schemas.openxmlformats.org/drawingml/2006/main">
               <a:ext uri="{FF2B5EF4-FFF2-40B4-BE49-F238E27FC236}">
-                <a16:creationId xmlns:a16="http://schemas.microsoft.com/office/drawing/2014/main" id="{2784A685-1C25-4739-9479-3630A580D77D}"/>
+                <a16:creationId xmlns:a16="http://schemas.microsoft.com/office/drawing/2014/main" id="{DE3571C8-CC88-42CE-B623-82880703F94C}"/>
               </a:ext>
             </a:extLst>
           </p:cNvPr>
@@ -4169,7 +4169,7 @@
           <p:cNvPr id="10" name="phase-http-1">
             <a:extLst xmlns:a="http://schemas.openxmlformats.org/drawingml/2006/main">
               <a:ext uri="{FF2B5EF4-FFF2-40B4-BE49-F238E27FC236}">
-                <a16:creationId xmlns:a16="http://schemas.microsoft.com/office/drawing/2014/main" id="{06580123-C9A3-4E80-831B-6C708F462C6A}"/>
+                <a16:creationId xmlns:a16="http://schemas.microsoft.com/office/drawing/2014/main" id="{6AE13730-A351-4D2C-A953-A1AD3C873D59}"/>
               </a:ext>
             </a:extLst>
           </p:cNvPr>
@@ -4225,7 +4225,7 @@
           <p:cNvPr id="11" name="arrow-2">
             <a:extLst xmlns:a="http://schemas.openxmlformats.org/drawingml/2006/main">
               <a:ext uri="{FF2B5EF4-FFF2-40B4-BE49-F238E27FC236}">
-                <a16:creationId xmlns:a16="http://schemas.microsoft.com/office/drawing/2014/main" id="{20923B26-3CA5-42C5-BEBC-3402BAB77E6B}"/>
+                <a16:creationId xmlns:a16="http://schemas.microsoft.com/office/drawing/2014/main" id="{A942B671-4EFD-40FC-8628-3D18C3E7FFA3}"/>
               </a:ext>
             </a:extLst>
           </p:cNvPr>
@@ -4281,7 +4281,7 @@
           <p:cNvPr id="12" name="phase-2">
             <a:extLst xmlns:a="http://schemas.openxmlformats.org/drawingml/2006/main">
               <a:ext uri="{FF2B5EF4-FFF2-40B4-BE49-F238E27FC236}">
-                <a16:creationId xmlns:a16="http://schemas.microsoft.com/office/drawing/2014/main" id="{432A0B7B-2753-4E49-9623-6095659F599D}"/>
+                <a16:creationId xmlns:a16="http://schemas.microsoft.com/office/drawing/2014/main" id="{2C5380C8-08C7-4A62-81E9-10DAAEC9D1A0}"/>
               </a:ext>
             </a:extLst>
           </p:cNvPr>
@@ -4316,7 +4316,7 @@
           <p:cNvPr id="13" name="phase-label-2">
             <a:extLst xmlns:a="http://schemas.openxmlformats.org/drawingml/2006/main">
               <a:ext uri="{FF2B5EF4-FFF2-40B4-BE49-F238E27FC236}">
-                <a16:creationId xmlns:a16="http://schemas.microsoft.com/office/drawing/2014/main" id="{C497E9CF-5413-4558-9FDD-684AB1366DB9}"/>
+                <a16:creationId xmlns:a16="http://schemas.microsoft.com/office/drawing/2014/main" id="{44F93C3B-1630-48A0-87A0-E34BF208906C}"/>
               </a:ext>
             </a:extLst>
           </p:cNvPr>
@@ -4395,7 +4395,7 @@
           <p:cNvPr id="14" name="phase-http-2">
             <a:extLst xmlns:a="http://schemas.openxmlformats.org/drawingml/2006/main">
               <a:ext uri="{FF2B5EF4-FFF2-40B4-BE49-F238E27FC236}">
-                <a16:creationId xmlns:a16="http://schemas.microsoft.com/office/drawing/2014/main" id="{767860F9-3517-46FB-8DB2-2D26EC68B91C}"/>
+                <a16:creationId xmlns:a16="http://schemas.microsoft.com/office/drawing/2014/main" id="{1EABD644-F355-4E63-A3C0-4C40E9EE57F7}"/>
               </a:ext>
             </a:extLst>
           </p:cNvPr>
@@ -4451,7 +4451,7 @@
           <p:cNvPr id="15" name="phase-3">
             <a:extLst xmlns:a="http://schemas.openxmlformats.org/drawingml/2006/main">
               <a:ext uri="{FF2B5EF4-FFF2-40B4-BE49-F238E27FC236}">
-                <a16:creationId xmlns:a16="http://schemas.microsoft.com/office/drawing/2014/main" id="{E64AA44B-4729-4FB0-AA17-CBFF4655D37B}"/>
+                <a16:creationId xmlns:a16="http://schemas.microsoft.com/office/drawing/2014/main" id="{88C13E14-ECA3-4A8D-AEB1-12A8A2B951E7}"/>
               </a:ext>
             </a:extLst>
           </p:cNvPr>
@@ -4486,7 +4486,7 @@
           <p:cNvPr id="16" name="phase-label-3">
             <a:extLst xmlns:a="http://schemas.openxmlformats.org/drawingml/2006/main">
               <a:ext uri="{FF2B5EF4-FFF2-40B4-BE49-F238E27FC236}">
-                <a16:creationId xmlns:a16="http://schemas.microsoft.com/office/drawing/2014/main" id="{7E4B26EC-BEB1-4C3D-8081-29603864DC22}"/>
+                <a16:creationId xmlns:a16="http://schemas.microsoft.com/office/drawing/2014/main" id="{C2394D85-BDC6-4D3E-9F38-5E0B65E18272}"/>
               </a:ext>
             </a:extLst>
           </p:cNvPr>
@@ -4565,7 +4565,7 @@
           <p:cNvPr id="17" name="phase-http-3">
             <a:extLst xmlns:a="http://schemas.openxmlformats.org/drawingml/2006/main">
               <a:ext uri="{FF2B5EF4-FFF2-40B4-BE49-F238E27FC236}">
-                <a16:creationId xmlns:a16="http://schemas.microsoft.com/office/drawing/2014/main" id="{6A6C3AF3-3A7C-43F3-B1E8-89834F493AF0}"/>
+                <a16:creationId xmlns:a16="http://schemas.microsoft.com/office/drawing/2014/main" id="{884B2FE5-FB57-4421-9A7A-E476FC168D13}"/>
               </a:ext>
             </a:extLst>
           </p:cNvPr>
@@ -4621,7 +4621,7 @@
           <p:cNvPr id="18" name="integrity-count">
             <a:extLst xmlns:a="http://schemas.openxmlformats.org/drawingml/2006/main">
               <a:ext uri="{FF2B5EF4-FFF2-40B4-BE49-F238E27FC236}">
-                <a16:creationId xmlns:a16="http://schemas.microsoft.com/office/drawing/2014/main" id="{8B9C66D0-8E04-484D-8C02-BEB87EF6C966}"/>
+                <a16:creationId xmlns:a16="http://schemas.microsoft.com/office/drawing/2014/main" id="{E32C6351-882A-4A72-9227-5974C7984657}"/>
               </a:ext>
             </a:extLst>
           </p:cNvPr>
@@ -4677,7 +4677,7 @@
           <p:cNvPr id="19" name="integrity-hash">
             <a:extLst xmlns:a="http://schemas.openxmlformats.org/drawingml/2006/main">
               <a:ext uri="{FF2B5EF4-FFF2-40B4-BE49-F238E27FC236}">
-                <a16:creationId xmlns:a16="http://schemas.microsoft.com/office/drawing/2014/main" id="{30945544-F938-4AE9-9341-2AB12566F1D8}"/>
+                <a16:creationId xmlns:a16="http://schemas.microsoft.com/office/drawing/2014/main" id="{4A91C376-C0C0-4F29-A738-E48467983F9B}"/>
               </a:ext>
             </a:extLst>
           </p:cNvPr>
@@ -4723,7 +4723,7 @@
                 <a:ea typeface="Malgun Gothic"/>
                 <a:cs typeface="Malgun Gothic"/>
               </a:rPr>
-              <a:t>콘텐츠 SHA-256 동일 · 첨부 SHA-256 동일 · 정적 계약 7/7</a:t>
+              <a:t>콘텐츠 SHA-256 동일 · 첨부 SHA-256 동일 · 정적 계약 8/8</a:t>
             </a:r>
           </a:p>
         </p:txBody>
@@ -4731,7 +4731,7 @@
     </p:spTree>
     <p:extLst>
       <p:ext uri="{BB962C8B-B14F-4D97-AF65-F5344CB8AC3E}">
-        <p14:creationId xmlns:p14="http://schemas.microsoft.com/office/powerpoint/2010/main" val="28413815"/>
+        <p14:creationId xmlns:p14="http://schemas.microsoft.com/office/powerpoint/2010/main" val="1778098845"/>
       </p:ext>
     </p:extLst>
   </p:cSld>
@@ -4762,7 +4762,7 @@
           <p:cNvPr id="16" name="title-6">
             <a:extLst xmlns:a="http://schemas.openxmlformats.org/drawingml/2006/main">
               <a:ext uri="{FF2B5EF4-FFF2-40B4-BE49-F238E27FC236}">
-                <a16:creationId xmlns:a16="http://schemas.microsoft.com/office/drawing/2014/main" id="{C2C6F4D2-9EE2-4FDD-BC52-173AF175D052}"/>
+                <a16:creationId xmlns:a16="http://schemas.microsoft.com/office/drawing/2014/main" id="{936FB80E-5395-4A55-AD96-BEDB34A10EA4}"/>
               </a:ext>
             </a:extLst>
           </p:cNvPr>
@@ -4818,7 +4818,7 @@
           <p:cNvPr id="2" name="page-6">
             <a:extLst xmlns:a="http://schemas.openxmlformats.org/drawingml/2006/main">
               <a:ext uri="{FF2B5EF4-FFF2-40B4-BE49-F238E27FC236}">
-                <a16:creationId xmlns:a16="http://schemas.microsoft.com/office/drawing/2014/main" id="{13D7E22A-AE64-475F-9196-E0C1A7F83D18}"/>
+                <a16:creationId xmlns:a16="http://schemas.microsoft.com/office/drawing/2014/main" id="{3F45BDCE-34E9-4077-B6E9-8798632294DA}"/>
               </a:ext>
             </a:extLst>
           </p:cNvPr>
@@ -4874,7 +4874,7 @@
           <p:cNvPr id="3" name="flow-arrow-1">
             <a:extLst xmlns:a="http://schemas.openxmlformats.org/drawingml/2006/main">
               <a:ext uri="{FF2B5EF4-FFF2-40B4-BE49-F238E27FC236}">
-                <a16:creationId xmlns:a16="http://schemas.microsoft.com/office/drawing/2014/main" id="{97EC3B7F-386C-4786-97DF-F409D48780AD}"/>
+                <a16:creationId xmlns:a16="http://schemas.microsoft.com/office/drawing/2014/main" id="{EB86C32F-C4FD-45E8-9497-343C1812BBDB}"/>
               </a:ext>
             </a:extLst>
           </p:cNvPr>
@@ -4930,7 +4930,7 @@
           <p:cNvPr id="4" name="flow-arrow-2">
             <a:extLst xmlns:a="http://schemas.openxmlformats.org/drawingml/2006/main">
               <a:ext uri="{FF2B5EF4-FFF2-40B4-BE49-F238E27FC236}">
-                <a16:creationId xmlns:a16="http://schemas.microsoft.com/office/drawing/2014/main" id="{E66F4DD0-920C-4E1B-AED5-9C85E6D3DDF2}"/>
+                <a16:creationId xmlns:a16="http://schemas.microsoft.com/office/drawing/2014/main" id="{6F22E331-7339-4254-919A-CCAE04D6ECA4}"/>
               </a:ext>
             </a:extLst>
           </p:cNvPr>
@@ -4986,7 +4986,7 @@
           <p:cNvPr id="5" name="flarum-core">
             <a:extLst xmlns:a="http://schemas.openxmlformats.org/drawingml/2006/main">
               <a:ext uri="{FF2B5EF4-FFF2-40B4-BE49-F238E27FC236}">
-                <a16:creationId xmlns:a16="http://schemas.microsoft.com/office/drawing/2014/main" id="{9CA3784D-5454-448A-8F5F-9E7D825DD376}"/>
+                <a16:creationId xmlns:a16="http://schemas.microsoft.com/office/drawing/2014/main" id="{DA23153E-79AE-48B3-A25B-D56C8D304631}"/>
               </a:ext>
             </a:extLst>
           </p:cNvPr>
@@ -5021,7 +5021,7 @@
           <p:cNvPr id="6" name="theme-extension">
             <a:extLst xmlns:a="http://schemas.openxmlformats.org/drawingml/2006/main">
               <a:ext uri="{FF2B5EF4-FFF2-40B4-BE49-F238E27FC236}">
-                <a16:creationId xmlns:a16="http://schemas.microsoft.com/office/drawing/2014/main" id="{E4ED5645-5B51-41AF-A900-421E4F43D1BC}"/>
+                <a16:creationId xmlns:a16="http://schemas.microsoft.com/office/drawing/2014/main" id="{FDE91976-7457-4CFE-B630-516C6F2F8910}"/>
               </a:ext>
             </a:extLst>
           </p:cNvPr>
@@ -5056,7 +5056,7 @@
           <p:cNvPr id="7" name="community-ui">
             <a:extLst xmlns:a="http://schemas.openxmlformats.org/drawingml/2006/main">
               <a:ext uri="{FF2B5EF4-FFF2-40B4-BE49-F238E27FC236}">
-                <a16:creationId xmlns:a16="http://schemas.microsoft.com/office/drawing/2014/main" id="{F39AAF2B-FB0D-44C8-B00D-5CF5CF3D9003}"/>
+                <a16:creationId xmlns:a16="http://schemas.microsoft.com/office/drawing/2014/main" id="{99C8A671-21F5-4CCE-984F-FFDA4482C553}"/>
               </a:ext>
             </a:extLst>
           </p:cNvPr>
@@ -5091,7 +5091,7 @@
           <p:cNvPr id="8" name="flarum-core-title">
             <a:extLst xmlns:a="http://schemas.openxmlformats.org/drawingml/2006/main">
               <a:ext uri="{FF2B5EF4-FFF2-40B4-BE49-F238E27FC236}">
-                <a16:creationId xmlns:a16="http://schemas.microsoft.com/office/drawing/2014/main" id="{25F1602E-147F-40D5-BB7F-7A4652B7C106}"/>
+                <a16:creationId xmlns:a16="http://schemas.microsoft.com/office/drawing/2014/main" id="{AEFC3C39-A8D6-49E8-A2CD-DCB6196FF1C3}"/>
               </a:ext>
             </a:extLst>
           </p:cNvPr>
@@ -5147,7 +5147,7 @@
           <p:cNvPr id="9" name="flarum-core-copy">
             <a:extLst xmlns:a="http://schemas.openxmlformats.org/drawingml/2006/main">
               <a:ext uri="{FF2B5EF4-FFF2-40B4-BE49-F238E27FC236}">
-                <a16:creationId xmlns:a16="http://schemas.microsoft.com/office/drawing/2014/main" id="{AA7CDD2A-CDBC-4BB6-8BF7-4C81D4D8C759}"/>
+                <a16:creationId xmlns:a16="http://schemas.microsoft.com/office/drawing/2014/main" id="{921626C5-662F-4967-BEC0-07F29A8DCED0}"/>
               </a:ext>
             </a:extLst>
           </p:cNvPr>
@@ -5203,7 +5203,7 @@
           <p:cNvPr id="10" name="theme-title">
             <a:extLst xmlns:a="http://schemas.openxmlformats.org/drawingml/2006/main">
               <a:ext uri="{FF2B5EF4-FFF2-40B4-BE49-F238E27FC236}">
-                <a16:creationId xmlns:a16="http://schemas.microsoft.com/office/drawing/2014/main" id="{C069B4FC-9974-45E8-8B0C-E5825BCF430B}"/>
+                <a16:creationId xmlns:a16="http://schemas.microsoft.com/office/drawing/2014/main" id="{C39A71F0-144B-4F5B-90E3-26EF4A4CB9EC}"/>
               </a:ext>
             </a:extLst>
           </p:cNvPr>
@@ -5282,7 +5282,7 @@
           <p:cNvPr id="11" name="theme-copy">
             <a:extLst xmlns:a="http://schemas.openxmlformats.org/drawingml/2006/main">
               <a:ext uri="{FF2B5EF4-FFF2-40B4-BE49-F238E27FC236}">
-                <a16:creationId xmlns:a16="http://schemas.microsoft.com/office/drawing/2014/main" id="{16017296-655A-4257-BDBA-713B8D5FD465}"/>
+                <a16:creationId xmlns:a16="http://schemas.microsoft.com/office/drawing/2014/main" id="{50BC9FF5-CF2D-4B73-8AF0-12FC42B1BD19}"/>
               </a:ext>
             </a:extLst>
           </p:cNvPr>
@@ -5338,7 +5338,7 @@
           <p:cNvPr id="12" name="ui-title">
             <a:extLst xmlns:a="http://schemas.openxmlformats.org/drawingml/2006/main">
               <a:ext uri="{FF2B5EF4-FFF2-40B4-BE49-F238E27FC236}">
-                <a16:creationId xmlns:a16="http://schemas.microsoft.com/office/drawing/2014/main" id="{8AA4CAC8-BB88-429F-A32A-BC5EF660BD9D}"/>
+                <a16:creationId xmlns:a16="http://schemas.microsoft.com/office/drawing/2014/main" id="{283B322A-01FC-48D8-8FCE-05C601059157}"/>
               </a:ext>
             </a:extLst>
           </p:cNvPr>
@@ -5394,7 +5394,7 @@
           <p:cNvPr id="13" name="ui-copy">
             <a:extLst xmlns:a="http://schemas.openxmlformats.org/drawingml/2006/main">
               <a:ext uri="{FF2B5EF4-FFF2-40B4-BE49-F238E27FC236}">
-                <a16:creationId xmlns:a16="http://schemas.microsoft.com/office/drawing/2014/main" id="{B78B82E9-1C01-471A-8A5A-094B891E2A0B}"/>
+                <a16:creationId xmlns:a16="http://schemas.microsoft.com/office/drawing/2014/main" id="{739BED58-F52D-47EA-90CA-37B122117631}"/>
               </a:ext>
             </a:extLst>
           </p:cNvPr>
@@ -5450,7 +5450,7 @@
           <p:cNvPr id="14" name="rollback-strip">
             <a:extLst xmlns:a="http://schemas.openxmlformats.org/drawingml/2006/main">
               <a:ext uri="{FF2B5EF4-FFF2-40B4-BE49-F238E27FC236}">
-                <a16:creationId xmlns:a16="http://schemas.microsoft.com/office/drawing/2014/main" id="{F1678DA7-86C2-45D4-B880-46856B6D82EB}"/>
+                <a16:creationId xmlns:a16="http://schemas.microsoft.com/office/drawing/2014/main" id="{62AD6541-9226-48D0-9347-826D4FFF9A1A}"/>
               </a:ext>
             </a:extLst>
           </p:cNvPr>
@@ -5485,7 +5485,7 @@
           <p:cNvPr id="15" name="rollback-copy">
             <a:extLst xmlns:a="http://schemas.openxmlformats.org/drawingml/2006/main">
               <a:ext uri="{FF2B5EF4-FFF2-40B4-BE49-F238E27FC236}">
-                <a16:creationId xmlns:a16="http://schemas.microsoft.com/office/drawing/2014/main" id="{5F1F7096-604A-46C3-937C-B66DBCC66B20}"/>
+                <a16:creationId xmlns:a16="http://schemas.microsoft.com/office/drawing/2014/main" id="{46F68522-A016-4317-82DD-1A7C7A60632F}"/>
               </a:ext>
             </a:extLst>
           </p:cNvPr>
@@ -5539,7 +5539,7 @@
     </p:spTree>
     <p:extLst>
       <p:ext uri="{BB962C8B-B14F-4D97-AF65-F5344CB8AC3E}">
-        <p14:creationId xmlns:p14="http://schemas.microsoft.com/office/powerpoint/2010/main" val="1822389716"/>
+        <p14:creationId xmlns:p14="http://schemas.microsoft.com/office/powerpoint/2010/main" val="492373279"/>
       </p:ext>
     </p:extLst>
   </p:cSld>
@@ -5570,7 +5570,7 @@
           <p:cNvPr id="8" name="close-kicker">
             <a:extLst xmlns:a="http://schemas.openxmlformats.org/drawingml/2006/main">
               <a:ext uri="{FF2B5EF4-FFF2-40B4-BE49-F238E27FC236}">
-                <a16:creationId xmlns:a16="http://schemas.microsoft.com/office/drawing/2014/main" id="{8845B3F0-8CA6-49C8-BD93-DDD1F8F83681}"/>
+                <a16:creationId xmlns:a16="http://schemas.microsoft.com/office/drawing/2014/main" id="{D1BDAAFA-749F-4F68-B0B3-D02CB6F0DE94}"/>
               </a:ext>
             </a:extLst>
           </p:cNvPr>
@@ -5626,7 +5626,7 @@
           <p:cNvPr id="2" name="close-title">
             <a:extLst xmlns:a="http://schemas.openxmlformats.org/drawingml/2006/main">
               <a:ext uri="{FF2B5EF4-FFF2-40B4-BE49-F238E27FC236}">
-                <a16:creationId xmlns:a16="http://schemas.microsoft.com/office/drawing/2014/main" id="{B90482D9-E49D-4A75-A7DD-D20A8403701F}"/>
+                <a16:creationId xmlns:a16="http://schemas.microsoft.com/office/drawing/2014/main" id="{79087787-4218-4B4D-9D5E-876C14FB2008}"/>
               </a:ext>
             </a:extLst>
           </p:cNvPr>
@@ -5705,7 +5705,7 @@
           <p:cNvPr id="3" name="close-detail">
             <a:extLst xmlns:a="http://schemas.openxmlformats.org/drawingml/2006/main">
               <a:ext uri="{FF2B5EF4-FFF2-40B4-BE49-F238E27FC236}">
-                <a16:creationId xmlns:a16="http://schemas.microsoft.com/office/drawing/2014/main" id="{07786C93-BD25-40E4-9FD9-D2A9C6876874}"/>
+                <a16:creationId xmlns:a16="http://schemas.microsoft.com/office/drawing/2014/main" id="{E2399564-ACA1-440B-8B67-6DA3C26096E3}"/>
               </a:ext>
             </a:extLst>
           </p:cNvPr>
@@ -5784,7 +5784,7 @@
           <p:cNvPr id="4" name="close-status">
             <a:extLst xmlns:a="http://schemas.openxmlformats.org/drawingml/2006/main">
               <a:ext uri="{FF2B5EF4-FFF2-40B4-BE49-F238E27FC236}">
-                <a16:creationId xmlns:a16="http://schemas.microsoft.com/office/drawing/2014/main" id="{4A99C6E8-A50F-478C-ABEC-15A175845BC5}"/>
+                <a16:creationId xmlns:a16="http://schemas.microsoft.com/office/drawing/2014/main" id="{B0D82F77-79CC-42A8-B90C-B3D5283F24E3}"/>
               </a:ext>
             </a:extLst>
           </p:cNvPr>
@@ -5819,7 +5819,7 @@
           <p:cNvPr id="5" name="close-go">
             <a:extLst xmlns:a="http://schemas.openxmlformats.org/drawingml/2006/main">
               <a:ext uri="{FF2B5EF4-FFF2-40B4-BE49-F238E27FC236}">
-                <a16:creationId xmlns:a16="http://schemas.microsoft.com/office/drawing/2014/main" id="{7216BC89-86DB-4940-84C2-0E9AD119D7E1}"/>
+                <a16:creationId xmlns:a16="http://schemas.microsoft.com/office/drawing/2014/main" id="{4C24718F-5617-4A4E-A7C3-4A6724066465}"/>
               </a:ext>
             </a:extLst>
           </p:cNvPr>
@@ -5875,7 +5875,7 @@
           <p:cNvPr id="6" name="close-condition">
             <a:extLst xmlns:a="http://schemas.openxmlformats.org/drawingml/2006/main">
               <a:ext uri="{FF2B5EF4-FFF2-40B4-BE49-F238E27FC236}">
-                <a16:creationId xmlns:a16="http://schemas.microsoft.com/office/drawing/2014/main" id="{A737D8EF-3E59-4E0F-B875-8CE04D6F1CD6}"/>
+                <a16:creationId xmlns:a16="http://schemas.microsoft.com/office/drawing/2014/main" id="{E0ED3DBD-A662-414D-BC4C-72CD92E82052}"/>
               </a:ext>
             </a:extLst>
           </p:cNvPr>
@@ -5931,7 +5931,7 @@
           <p:cNvPr id="7" name="close-next">
             <a:extLst xmlns:a="http://schemas.openxmlformats.org/drawingml/2006/main">
               <a:ext uri="{FF2B5EF4-FFF2-40B4-BE49-F238E27FC236}">
-                <a16:creationId xmlns:a16="http://schemas.microsoft.com/office/drawing/2014/main" id="{75AB3431-1F98-4F70-9CF4-B76ADFF23BE4}"/>
+                <a16:creationId xmlns:a16="http://schemas.microsoft.com/office/drawing/2014/main" id="{260A11F1-9615-4262-91E0-CDC2F64E7EC4}"/>
               </a:ext>
             </a:extLst>
           </p:cNvPr>
@@ -5985,7 +5985,7 @@
     </p:spTree>
     <p:extLst>
       <p:ext uri="{BB962C8B-B14F-4D97-AF65-F5344CB8AC3E}">
-        <p14:creationId xmlns:p14="http://schemas.microsoft.com/office/powerpoint/2010/main" val="145209803"/>
+        <p14:creationId xmlns:p14="http://schemas.microsoft.com/office/powerpoint/2010/main" val="1153721952"/>
       </p:ext>
     </p:extLst>
   </p:cSld>

</xml_diff>